<commit_message>
Presentation: white background, remove lecture references from figures
Slide figures in output/figures/slides_en are recoloured to a pure white
background and the '(L4)' references are cut from the backtest and
calendar-effect captions; data and geometry are unchanged. The two
headerless backtest panels used on slide 4 are saved as
slides_en/backtest_quality.png and slides_en/monthly_coverage.png.
The deck and its PDF preview are rebuilt with these images and white
slide backgrounds.
</commit_message>
<xml_diff>
--- a/output/presentation/lenin_stalin_forecast_final.pptx
+++ b/output/presentation/lenin_stalin_forecast_final.pptx
@@ -3879,7 +3879,7 @@
     <p:bg>
       <p:bgPr>
         <a:solidFill xmlns:a="http://schemas.openxmlformats.org/drawingml/2006/main">
-          <a:srgbClr val="FAFAF8"/>
+          <a:srgbClr val="FFFFFF"/>
         </a:solidFill>
       </p:bgPr>
     </p:bg>
@@ -6132,7 +6132,7 @@
     <p:bg>
       <p:bgPr>
         <a:solidFill xmlns:a="http://schemas.openxmlformats.org/drawingml/2006/main">
-          <a:srgbClr val="FAFAF8"/>
+          <a:srgbClr val="FFFFFF"/>
         </a:solidFill>
       </p:bgPr>
     </p:bg>
@@ -7615,7 +7615,7 @@
     <p:bg>
       <p:bgPr>
         <a:solidFill xmlns:a="http://schemas.openxmlformats.org/drawingml/2006/main">
-          <a:srgbClr val="FAFAF8"/>
+          <a:srgbClr val="FFFFFF"/>
         </a:solidFill>
       </p:bgPr>
     </p:bg>
@@ -10568,7 +10568,7 @@
     <p:bg>
       <p:bgPr>
         <a:solidFill xmlns:a="http://schemas.openxmlformats.org/drawingml/2006/main">
-          <a:srgbClr val="FAFAF8"/>
+          <a:srgbClr val="FFFFFF"/>
         </a:solidFill>
       </p:bgPr>
     </p:bg>
@@ -12043,7 +12043,7 @@
     <p:bg>
       <p:bgPr>
         <a:solidFill xmlns:a="http://schemas.openxmlformats.org/drawingml/2006/main">
-          <a:srgbClr val="FAFAF8"/>
+          <a:srgbClr val="FFFFFF"/>
         </a:solidFill>
       </p:bgPr>
     </p:bg>
@@ -13696,7 +13696,7 @@
     <p:bg>
       <p:bgPr>
         <a:solidFill xmlns:a="http://schemas.openxmlformats.org/drawingml/2006/main">
-          <a:srgbClr val="FAFAF8"/>
+          <a:srgbClr val="FFFFFF"/>
         </a:solidFill>
       </p:bgPr>
     </p:bg>
@@ -14919,7 +14919,7 @@
     <p:bg>
       <p:bgPr>
         <a:solidFill xmlns:a="http://schemas.openxmlformats.org/drawingml/2006/main">
-          <a:srgbClr val="FAFAF8"/>
+          <a:srgbClr val="FFFFFF"/>
         </a:solidFill>
       </p:bgPr>
     </p:bg>

</xml_diff>